<commit_message>
fix: date timezone parsing, low-volume false critical alerts, and dashboard metric sync (96 passing tests)
</commit_message>
<xml_diff>
--- a/ZeroSec_DevSprint_PS04_Presentation.pptx
+++ b/ZeroSec_DevSprint_PS04_Presentation.pptx
@@ -2493,7 +2493,7 @@
               </a:defRPr>
             </a:pPr>
             <a:r>
-              <a:t>- Summary: An autonomous anomaly intelligence engine that derives per-campaign volatility bands (mu +- 2*sigma) to catch 100% of incidents while suppressing &gt;97% of noise.</a:t>
+              <a:t>- Summary: An autonomous anomaly intelligence engine that derives per-campaign volatility bands (rolling median / MAD &amp; Poisson tails) to catch real incidents while achieving 94.2% noise reduction vs naive thresholds.</a:t>
             </a:r>
           </a:p>
           <a:p>
@@ -2508,7 +2508,7 @@
               </a:defRPr>
             </a:pPr>
             <a:r>
-              <a:t>- Dynamic Volatility Modeling: Calculates 14-day rolling baselines per campaign rather than using an arbitrary, rigid global percentage threshold.</a:t>
+              <a:t>- Dynamic Volatility Modeling: Calculates 28-day rolling baselines per campaign rather than using an arbitrary, rigid global percentage threshold.</a:t>
             </a:r>
           </a:p>
           <a:p>
@@ -2538,7 +2538,7 @@
               </a:defRPr>
             </a:pPr>
             <a:r>
-              <a:t>- Cooldown Suppression: Automatically groups multi-day sustained anomalies to prevent repetitive duplicate notification spam.</a:t>
+              <a:t>- Cooldown Suppression Shield: Automatically groups multi-day sustained anomalies and suppresses redundant alerts inside cooldown windows.</a:t>
             </a:r>
           </a:p>
           <a:p>
@@ -2553,7 +2553,7 @@
               </a:defRPr>
             </a:pPr>
             <a:r>
-              <a:t>- Automated Diagnosis: Every alert includes a plain-English explanation and a step-by-step diagnostic playbook for rapid engineering resolution.</a:t>
+              <a:t>- Automated Diagnosis: Every alert includes a plain-English explanation, measured evidence, and an actionable diagnostic playbook.</a:t>
             </a:r>
           </a:p>
         </p:txBody>
@@ -2639,7 +2639,7 @@
               </a:defRPr>
             </a:pPr>
             <a:r>
-              <a:t>Flow: 180-Day Metrics Ingestion -&gt; Dynamic Baselines (mu +- 2*sigma) &amp; Cooldown -&gt; Actionable Alerts + Playbooks</a:t>
+              <a:t>Flow: 180-Day Ingestion -&gt; Rolling Median/MAD &amp; Poisson Baselines -&gt; Grouping &amp; Cooldown -&gt; Actionable Alerts</a:t>
             </a:r>
             <a:endParaRPr lang="en-US" sz="1600" dirty="0"/>
           </a:p>
@@ -2830,7 +2830,7 @@
               </a:defRPr>
             </a:pPr>
             <a:r>
-              <a:t>- Frontend: React 18, Vite, TypeScript, Tailwind CSS, Lucide Icons, Recharts (Composed time-series, confidence envelopes &amp; confusion matrix).</a:t>
+              <a:t>- Frontend: React 18, Vite, TypeScript, Tailwind CSS, Lucide Icons, Recharts (Composed time-series, confidence envelopes &amp; evaluation matrix).</a:t>
             </a:r>
           </a:p>
           <a:p>
@@ -2845,7 +2845,7 @@
               </a:defRPr>
             </a:pPr>
             <a:r>
-              <a:t>- Backend &amp; API: Python 3.10+, FastAPI REST microservice (/analyze, /demo-data, /health), Uvicorn, Pytest (91 unit tests passing, 100% green).</a:t>
+              <a:t>- Backend &amp; API: Python 3.10+, FastAPI REST microservice (/analyze, /demo-data, /health), Uvicorn, Pytest (96 unit tests passing, 100% green).</a:t>
             </a:r>
           </a:p>
           <a:p>
@@ -2860,7 +2860,7 @@
               </a:defRPr>
             </a:pPr>
             <a:r>
-              <a:t>- Statistical Core: Rolling mean (mu) &amp; standard deviation (sigma), dynamic Z-Score outlier detection, and spend-floor safety guardrails (Rs 250 floor).</a:t>
+              <a:t>- Statistical Core: Rolling median &amp; MAD with Student-t small-sample correction for continuous metrics, exact Poisson tail for counts, and low-volume guards.</a:t>
             </a:r>
           </a:p>
           <a:p>
@@ -2875,7 +2875,7 @@
               </a:defRPr>
             </a:pPr>
             <a:r>
-              <a:t>- Step-by-Step Delivery: Statistical engine validated with 91 tests -&gt; FastAPI microservice built -&gt; Interactive React dashboard built -&gt; 1-click Markdown RCA export.</a:t>
+              <a:t>- Step-by-Step Delivery: Statistical engine validated with 96 tests -&gt; FastAPI microservice built -&gt; Interactive React dashboard built -&gt; 1-click Markdown RCA export.</a:t>
             </a:r>
           </a:p>
         </p:txBody>
@@ -2961,7 +2961,7 @@
               </a:defRPr>
             </a:pPr>
             <a:r>
-              <a:t>Tech Stack: React 18 + Vite | Python FastAPI Microservice | 91 Passing Pytest Unit Tests</a:t>
+              <a:t>Tech Stack: React 18 + Vite | Python FastAPI Microservice | 96 Passing Pytest Unit Tests</a:t>
             </a:r>
             <a:endParaRPr lang="en-US" sz="1600" dirty="0"/>
           </a:p>
@@ -3136,7 +3136,7 @@
               </a:defRPr>
             </a:pPr>
             <a:r>
-              <a:t>Measurable Gains &amp; Ground-Truth Accuracy</a:t>
+              <a:t>Measurable Empirical Benchmarks (Synthetic 180-Day Dataset)</a:t>
             </a:r>
             <a:endParaRPr lang="en-US" sz="1400" dirty="0"/>
           </a:p>
@@ -3152,7 +3152,7 @@
               </a:defRPr>
             </a:pPr>
             <a:r>
-              <a:t>- 100.0% Incident Recall: Successfully detected 4 out of 4 ground-truth incident windows (0 missed real emergencies across 180 days).</a:t>
+              <a:t>- 100% Immediate Alert Precision: 4 out of 4 immediate incident alerts matched real emergencies on Day 0 (zero false emergency pages).</a:t>
             </a:r>
           </a:p>
           <a:p>
@@ -3167,7 +3167,7 @@
               </a:defRPr>
             </a:pPr>
             <a:r>
-              <a:t>- &gt;97% Noise Reduction: Replaced 1,103 false alerts from naive rules with only 5 actionable emergency incidents and quiet background digests.</a:t>
+              <a:t>- 94.2% Alert Reduction vs Naive Baseline: Replaced 1,103 noisy alerts from naive ±30% rules with 64 managed notifications (4 immediate, 60 digest).</a:t>
             </a:r>
           </a:p>
           <a:p>
@@ -3182,7 +3182,7 @@
               </a:defRPr>
             </a:pPr>
             <a:r>
-              <a:t>- &lt;0.7% False Alarm Rate: Across 3,571 normal operating campaign-days, normal days stay quiet without crying wolf.</a:t>
+              <a:t>- 178 Multi-Metric Anomalies Grouped: Correlated anomalies across spend, clicks, and conversions merged into cohesive campaign incident episodes.</a:t>
             </a:r>
           </a:p>
           <a:p>
@@ -3197,7 +3197,7 @@
               </a:defRPr>
             </a:pPr>
             <a:r>
-              <a:t>- 85% Faster Triage: Automated diagnostic playbooks eliminate 2-3 hours of manual metric auditing and data scraping per incident.</a:t>
+              <a:t>- 95 Repetitive Findings Suppressed: Cooldown shield prevents fatigue by suppressing recurring notifications while an outage is already acknowledged.</a:t>
             </a:r>
           </a:p>
           <a:p>
@@ -3212,7 +3212,7 @@
               </a:defRPr>
             </a:pPr>
             <a:r>
-              <a:t>- Direct Revenue Protection: Catches zero-conversion tag drops and runaway CPC spikes before they drain campaign budgets.</a:t>
+              <a:t>- Automated Diagnostic Playbooks: Root cause hypotheses and step-by-step diagnostic checklists generated for every incident to streamline triage.</a:t>
             </a:r>
           </a:p>
         </p:txBody>
@@ -3298,7 +3298,7 @@
               </a:defRPr>
             </a:pPr>
             <a:r>
-              <a:t>Measurable Impact: 100% Recall (0 Missed Incidents) with &gt;97% Noise Reduction vs Naive Rules</a:t>
+              <a:t>Empirical Impact: 94.2% Alert Reduction vs Naive Rules (64 Managed Alerts vs 1,103 Naive Fired)</a:t>
             </a:r>
             <a:endParaRPr lang="en-US" sz="1600" dirty="0"/>
           </a:p>
@@ -3842,7 +3842,7 @@
               </a:defRPr>
             </a:pPr>
             <a:r>
-              <a:t>- Transparent Accuracy: Ground-truth 4-cell confusion matrix reporting 100% Recall, 0 missed emergencies, and &lt;0.7% false alarm rate.</a:t>
+              <a:t>- Transparent Accuracy: 94.2% alert noise reduction, 100% immediate alert precision, and transparently reported false-positive benchmarks.</a:t>
             </a:r>
           </a:p>
           <a:p>
@@ -3857,7 +3857,7 @@
               </a:defRPr>
             </a:pPr>
             <a:r>
-              <a:t>- Complete Submission: Full-stack implementation, 91 passing tests, complete documentation, and PDF functional report.</a:t>
+              <a:t>- Complete Submission: Full-stack implementation, 96 passing tests, complete documentation, and PDF functional report.</a:t>
             </a:r>
           </a:p>
           <a:p>

</xml_diff>